<commit_message>
adding pdf slide ads
</commit_message>
<xml_diff>
--- a/assets/slides/Engineering Data Science.pptx
+++ b/assets/slides/Engineering Data Science.pptx
@@ -239,7 +239,7 @@
           <a:p>
             <a:fld id="{D6F60BA2-1DFE-4286-AB71-68BFEBE24C91}" type="datetimeFigureOut">
               <a:rPr lang="en-GB" smtClean="0"/>
-              <a:t>05/11/2024</a:t>
+              <a:t>07/04/2025</a:t>
             </a:fld>
             <a:endParaRPr lang="en-GB"/>
           </a:p>
@@ -1820,7 +1820,7 @@
           <a:p>
             <a:fld id="{1A77EDC3-57CA-43CF-8E2C-C9B9AF002A04}" type="datetimeFigureOut">
               <a:rPr lang="en-GB" smtClean="0"/>
-              <a:t>05/11/2024</a:t>
+              <a:t>07/04/2025</a:t>
             </a:fld>
             <a:endParaRPr lang="en-GB"/>
           </a:p>
@@ -2020,7 +2020,7 @@
           <a:p>
             <a:fld id="{1A77EDC3-57CA-43CF-8E2C-C9B9AF002A04}" type="datetimeFigureOut">
               <a:rPr lang="en-GB" smtClean="0"/>
-              <a:t>05/11/2024</a:t>
+              <a:t>07/04/2025</a:t>
             </a:fld>
             <a:endParaRPr lang="en-GB"/>
           </a:p>
@@ -2230,7 +2230,7 @@
           <a:p>
             <a:fld id="{1A77EDC3-57CA-43CF-8E2C-C9B9AF002A04}" type="datetimeFigureOut">
               <a:rPr lang="en-GB" smtClean="0"/>
-              <a:t>05/11/2024</a:t>
+              <a:t>07/04/2025</a:t>
             </a:fld>
             <a:endParaRPr lang="en-GB"/>
           </a:p>
@@ -2430,7 +2430,7 @@
           <a:p>
             <a:fld id="{1A77EDC3-57CA-43CF-8E2C-C9B9AF002A04}" type="datetimeFigureOut">
               <a:rPr lang="en-GB" smtClean="0"/>
-              <a:t>05/11/2024</a:t>
+              <a:t>07/04/2025</a:t>
             </a:fld>
             <a:endParaRPr lang="en-GB"/>
           </a:p>
@@ -2706,7 +2706,7 @@
           <a:p>
             <a:fld id="{1A77EDC3-57CA-43CF-8E2C-C9B9AF002A04}" type="datetimeFigureOut">
               <a:rPr lang="en-GB" smtClean="0"/>
-              <a:t>05/11/2024</a:t>
+              <a:t>07/04/2025</a:t>
             </a:fld>
             <a:endParaRPr lang="en-GB"/>
           </a:p>
@@ -2974,7 +2974,7 @@
           <a:p>
             <a:fld id="{1A77EDC3-57CA-43CF-8E2C-C9B9AF002A04}" type="datetimeFigureOut">
               <a:rPr lang="en-GB" smtClean="0"/>
-              <a:t>05/11/2024</a:t>
+              <a:t>07/04/2025</a:t>
             </a:fld>
             <a:endParaRPr lang="en-GB"/>
           </a:p>
@@ -3389,7 +3389,7 @@
           <a:p>
             <a:fld id="{1A77EDC3-57CA-43CF-8E2C-C9B9AF002A04}" type="datetimeFigureOut">
               <a:rPr lang="en-GB" smtClean="0"/>
-              <a:t>05/11/2024</a:t>
+              <a:t>07/04/2025</a:t>
             </a:fld>
             <a:endParaRPr lang="en-GB"/>
           </a:p>
@@ -3531,7 +3531,7 @@
           <a:p>
             <a:fld id="{1A77EDC3-57CA-43CF-8E2C-C9B9AF002A04}" type="datetimeFigureOut">
               <a:rPr lang="en-GB" smtClean="0"/>
-              <a:t>05/11/2024</a:t>
+              <a:t>07/04/2025</a:t>
             </a:fld>
             <a:endParaRPr lang="en-GB"/>
           </a:p>
@@ -3644,7 +3644,7 @@
           <a:p>
             <a:fld id="{1A77EDC3-57CA-43CF-8E2C-C9B9AF002A04}" type="datetimeFigureOut">
               <a:rPr lang="en-GB" smtClean="0"/>
-              <a:t>05/11/2024</a:t>
+              <a:t>07/04/2025</a:t>
             </a:fld>
             <a:endParaRPr lang="en-GB"/>
           </a:p>
@@ -3957,7 +3957,7 @@
           <a:p>
             <a:fld id="{1A77EDC3-57CA-43CF-8E2C-C9B9AF002A04}" type="datetimeFigureOut">
               <a:rPr lang="en-GB" smtClean="0"/>
-              <a:t>05/11/2024</a:t>
+              <a:t>07/04/2025</a:t>
             </a:fld>
             <a:endParaRPr lang="en-GB"/>
           </a:p>
@@ -4246,7 +4246,7 @@
           <a:p>
             <a:fld id="{1A77EDC3-57CA-43CF-8E2C-C9B9AF002A04}" type="datetimeFigureOut">
               <a:rPr lang="en-GB" smtClean="0"/>
-              <a:t>05/11/2024</a:t>
+              <a:t>07/04/2025</a:t>
             </a:fld>
             <a:endParaRPr lang="en-GB"/>
           </a:p>
@@ -4489,7 +4489,7 @@
           <a:p>
             <a:fld id="{1A77EDC3-57CA-43CF-8E2C-C9B9AF002A04}" type="datetimeFigureOut">
               <a:rPr lang="en-GB" smtClean="0"/>
-              <a:t>05/11/2024</a:t>
+              <a:t>07/04/2025</a:t>
             </a:fld>
             <a:endParaRPr lang="en-GB"/>
           </a:p>

</xml_diff>

<commit_message>
updating name formatting practical session 2
</commit_message>
<xml_diff>
--- a/assets/slides/Engineering Data Science.pptx
+++ b/assets/slides/Engineering Data Science.pptx
@@ -239,7 +239,7 @@
           <a:p>
             <a:fld id="{D6F60BA2-1DFE-4286-AB71-68BFEBE24C91}" type="datetimeFigureOut">
               <a:rPr lang="en-GB" smtClean="0"/>
-              <a:t>21/05/2025</a:t>
+              <a:t>27/05/2025</a:t>
             </a:fld>
             <a:endParaRPr lang="en-GB"/>
           </a:p>
@@ -1904,7 +1904,7 @@
           <a:p>
             <a:fld id="{1A77EDC3-57CA-43CF-8E2C-C9B9AF002A04}" type="datetimeFigureOut">
               <a:rPr lang="en-GB" smtClean="0"/>
-              <a:t>21/05/2025</a:t>
+              <a:t>27/05/2025</a:t>
             </a:fld>
             <a:endParaRPr lang="en-GB"/>
           </a:p>
@@ -2104,7 +2104,7 @@
           <a:p>
             <a:fld id="{1A77EDC3-57CA-43CF-8E2C-C9B9AF002A04}" type="datetimeFigureOut">
               <a:rPr lang="en-GB" smtClean="0"/>
-              <a:t>21/05/2025</a:t>
+              <a:t>27/05/2025</a:t>
             </a:fld>
             <a:endParaRPr lang="en-GB"/>
           </a:p>
@@ -2314,7 +2314,7 @@
           <a:p>
             <a:fld id="{1A77EDC3-57CA-43CF-8E2C-C9B9AF002A04}" type="datetimeFigureOut">
               <a:rPr lang="en-GB" smtClean="0"/>
-              <a:t>21/05/2025</a:t>
+              <a:t>27/05/2025</a:t>
             </a:fld>
             <a:endParaRPr lang="en-GB"/>
           </a:p>
@@ -2514,7 +2514,7 @@
           <a:p>
             <a:fld id="{1A77EDC3-57CA-43CF-8E2C-C9B9AF002A04}" type="datetimeFigureOut">
               <a:rPr lang="en-GB" smtClean="0"/>
-              <a:t>21/05/2025</a:t>
+              <a:t>27/05/2025</a:t>
             </a:fld>
             <a:endParaRPr lang="en-GB"/>
           </a:p>
@@ -2790,7 +2790,7 @@
           <a:p>
             <a:fld id="{1A77EDC3-57CA-43CF-8E2C-C9B9AF002A04}" type="datetimeFigureOut">
               <a:rPr lang="en-GB" smtClean="0"/>
-              <a:t>21/05/2025</a:t>
+              <a:t>27/05/2025</a:t>
             </a:fld>
             <a:endParaRPr lang="en-GB"/>
           </a:p>
@@ -3058,7 +3058,7 @@
           <a:p>
             <a:fld id="{1A77EDC3-57CA-43CF-8E2C-C9B9AF002A04}" type="datetimeFigureOut">
               <a:rPr lang="en-GB" smtClean="0"/>
-              <a:t>21/05/2025</a:t>
+              <a:t>27/05/2025</a:t>
             </a:fld>
             <a:endParaRPr lang="en-GB"/>
           </a:p>
@@ -3473,7 +3473,7 @@
           <a:p>
             <a:fld id="{1A77EDC3-57CA-43CF-8E2C-C9B9AF002A04}" type="datetimeFigureOut">
               <a:rPr lang="en-GB" smtClean="0"/>
-              <a:t>21/05/2025</a:t>
+              <a:t>27/05/2025</a:t>
             </a:fld>
             <a:endParaRPr lang="en-GB"/>
           </a:p>
@@ -3615,7 +3615,7 @@
           <a:p>
             <a:fld id="{1A77EDC3-57CA-43CF-8E2C-C9B9AF002A04}" type="datetimeFigureOut">
               <a:rPr lang="en-GB" smtClean="0"/>
-              <a:t>21/05/2025</a:t>
+              <a:t>27/05/2025</a:t>
             </a:fld>
             <a:endParaRPr lang="en-GB"/>
           </a:p>
@@ -3728,7 +3728,7 @@
           <a:p>
             <a:fld id="{1A77EDC3-57CA-43CF-8E2C-C9B9AF002A04}" type="datetimeFigureOut">
               <a:rPr lang="en-GB" smtClean="0"/>
-              <a:t>21/05/2025</a:t>
+              <a:t>27/05/2025</a:t>
             </a:fld>
             <a:endParaRPr lang="en-GB"/>
           </a:p>
@@ -4041,7 +4041,7 @@
           <a:p>
             <a:fld id="{1A77EDC3-57CA-43CF-8E2C-C9B9AF002A04}" type="datetimeFigureOut">
               <a:rPr lang="en-GB" smtClean="0"/>
-              <a:t>21/05/2025</a:t>
+              <a:t>27/05/2025</a:t>
             </a:fld>
             <a:endParaRPr lang="en-GB"/>
           </a:p>
@@ -4330,7 +4330,7 @@
           <a:p>
             <a:fld id="{1A77EDC3-57CA-43CF-8E2C-C9B9AF002A04}" type="datetimeFigureOut">
               <a:rPr lang="en-GB" smtClean="0"/>
-              <a:t>21/05/2025</a:t>
+              <a:t>27/05/2025</a:t>
             </a:fld>
             <a:endParaRPr lang="en-GB"/>
           </a:p>
@@ -4573,7 +4573,7 @@
           <a:p>
             <a:fld id="{1A77EDC3-57CA-43CF-8E2C-C9B9AF002A04}" type="datetimeFigureOut">
               <a:rPr lang="en-GB" smtClean="0"/>
-              <a:t>21/05/2025</a:t>
+              <a:t>27/05/2025</a:t>
             </a:fld>
             <a:endParaRPr lang="en-GB"/>
           </a:p>
@@ -20585,6 +20585,60 @@
       </p:grpSpPr>
       <p:sp>
         <p:nvSpPr>
+          <p:cNvPr id="3" name="Rectangle 2">
+            <a:extLst>
+              <a:ext uri="{FF2B5EF4-FFF2-40B4-BE49-F238E27FC236}">
+                <a16:creationId xmlns:a16="http://schemas.microsoft.com/office/drawing/2014/main" id="{4DCA9595-E869-5E7F-2EF8-A7425D57DE28}"/>
+              </a:ext>
+            </a:extLst>
+          </p:cNvPr>
+          <p:cNvSpPr/>
+          <p:nvPr/>
+        </p:nvSpPr>
+        <p:spPr>
+          <a:xfrm>
+            <a:off x="3051110" y="2453951"/>
+            <a:ext cx="6074229" cy="3405673"/>
+          </a:xfrm>
+          <a:prstGeom prst="rect">
+            <a:avLst/>
+          </a:prstGeom>
+          <a:solidFill>
+            <a:schemeClr val="bg1"/>
+          </a:solidFill>
+          <a:ln>
+            <a:solidFill>
+              <a:schemeClr val="bg1"/>
+            </a:solidFill>
+          </a:ln>
+        </p:spPr>
+        <p:style>
+          <a:lnRef idx="2">
+            <a:schemeClr val="accent1">
+              <a:shade val="15000"/>
+            </a:schemeClr>
+          </a:lnRef>
+          <a:fillRef idx="1">
+            <a:schemeClr val="accent1"/>
+          </a:fillRef>
+          <a:effectRef idx="0">
+            <a:schemeClr val="accent1"/>
+          </a:effectRef>
+          <a:fontRef idx="minor">
+            <a:schemeClr val="lt1"/>
+          </a:fontRef>
+        </p:style>
+        <p:txBody>
+          <a:bodyPr rtlCol="0" anchor="ctr"/>
+          <a:lstStyle/>
+          <a:p>
+            <a:pPr algn="ctr"/>
+            <a:endParaRPr lang="en-GB"/>
+          </a:p>
+        </p:txBody>
+      </p:sp>
+      <p:sp>
+        <p:nvSpPr>
           <p:cNvPr id="5" name="Title 1">
             <a:extLst>
               <a:ext uri="{FF2B5EF4-FFF2-40B4-BE49-F238E27FC236}">
@@ -20865,6 +20919,60 @@
           <a:chExt cx="0" cy="0"/>
         </a:xfrm>
       </p:grpSpPr>
+      <p:sp>
+        <p:nvSpPr>
+          <p:cNvPr id="2" name="Rectangle 1">
+            <a:extLst>
+              <a:ext uri="{FF2B5EF4-FFF2-40B4-BE49-F238E27FC236}">
+                <a16:creationId xmlns:a16="http://schemas.microsoft.com/office/drawing/2014/main" id="{44F691A6-D397-A5C1-8D1F-9933E3A9544F}"/>
+              </a:ext>
+            </a:extLst>
+          </p:cNvPr>
+          <p:cNvSpPr/>
+          <p:nvPr/>
+        </p:nvSpPr>
+        <p:spPr>
+          <a:xfrm>
+            <a:off x="3051110" y="2453951"/>
+            <a:ext cx="6074229" cy="3405673"/>
+          </a:xfrm>
+          <a:prstGeom prst="rect">
+            <a:avLst/>
+          </a:prstGeom>
+          <a:solidFill>
+            <a:schemeClr val="bg1"/>
+          </a:solidFill>
+          <a:ln>
+            <a:solidFill>
+              <a:schemeClr val="bg1"/>
+            </a:solidFill>
+          </a:ln>
+        </p:spPr>
+        <p:style>
+          <a:lnRef idx="2">
+            <a:schemeClr val="accent1">
+              <a:shade val="15000"/>
+            </a:schemeClr>
+          </a:lnRef>
+          <a:fillRef idx="1">
+            <a:schemeClr val="accent1"/>
+          </a:fillRef>
+          <a:effectRef idx="0">
+            <a:schemeClr val="accent1"/>
+          </a:effectRef>
+          <a:fontRef idx="minor">
+            <a:schemeClr val="lt1"/>
+          </a:fontRef>
+        </p:style>
+        <p:txBody>
+          <a:bodyPr rtlCol="0" anchor="ctr"/>
+          <a:lstStyle/>
+          <a:p>
+            <a:pPr algn="ctr"/>
+            <a:endParaRPr lang="en-GB"/>
+          </a:p>
+        </p:txBody>
+      </p:sp>
       <p:sp>
         <p:nvSpPr>
           <p:cNvPr id="5" name="Title 1">
@@ -21283,6 +21391,60 @@
       </p:grpSpPr>
       <p:sp>
         <p:nvSpPr>
+          <p:cNvPr id="2" name="Rectangle 1">
+            <a:extLst>
+              <a:ext uri="{FF2B5EF4-FFF2-40B4-BE49-F238E27FC236}">
+                <a16:creationId xmlns:a16="http://schemas.microsoft.com/office/drawing/2014/main" id="{B8B66AB6-5DE9-55E8-0786-940DA7CEE3BF}"/>
+              </a:ext>
+            </a:extLst>
+          </p:cNvPr>
+          <p:cNvSpPr/>
+          <p:nvPr/>
+        </p:nvSpPr>
+        <p:spPr>
+          <a:xfrm>
+            <a:off x="3051110" y="2453951"/>
+            <a:ext cx="6074229" cy="3405673"/>
+          </a:xfrm>
+          <a:prstGeom prst="rect">
+            <a:avLst/>
+          </a:prstGeom>
+          <a:solidFill>
+            <a:schemeClr val="bg1"/>
+          </a:solidFill>
+          <a:ln>
+            <a:solidFill>
+              <a:schemeClr val="bg1"/>
+            </a:solidFill>
+          </a:ln>
+        </p:spPr>
+        <p:style>
+          <a:lnRef idx="2">
+            <a:schemeClr val="accent1">
+              <a:shade val="15000"/>
+            </a:schemeClr>
+          </a:lnRef>
+          <a:fillRef idx="1">
+            <a:schemeClr val="accent1"/>
+          </a:fillRef>
+          <a:effectRef idx="0">
+            <a:schemeClr val="accent1"/>
+          </a:effectRef>
+          <a:fontRef idx="minor">
+            <a:schemeClr val="lt1"/>
+          </a:fontRef>
+        </p:style>
+        <p:txBody>
+          <a:bodyPr rtlCol="0" anchor="ctr"/>
+          <a:lstStyle/>
+          <a:p>
+            <a:pPr algn="ctr"/>
+            <a:endParaRPr lang="en-GB"/>
+          </a:p>
+        </p:txBody>
+      </p:sp>
+      <p:sp>
+        <p:nvSpPr>
           <p:cNvPr id="5" name="Title 1">
             <a:extLst>
               <a:ext uri="{FF2B5EF4-FFF2-40B4-BE49-F238E27FC236}">
@@ -21726,7 +21888,7 @@
         <p:spPr>
           <a:xfrm>
             <a:off x="7563347" y="2568095"/>
-            <a:ext cx="1397947" cy="369332"/>
+            <a:ext cx="1255280" cy="369332"/>
           </a:xfrm>
           <a:prstGeom prst="rect">
             <a:avLst/>
@@ -21745,7 +21907,7 @@
                   <a:srgbClr val="003E74"/>
                 </a:solidFill>
               </a:rPr>
-              <a:t>ADS Library</a:t>
+              <a:t>DS Library</a:t>
             </a:r>
             <a:endParaRPr lang="en-GB" b="1" dirty="0">
               <a:solidFill>

</xml_diff>